<commit_message>
Add audience targeting and per-slide glossary footers
- generator/gui.py: new "발표 대상" field (초등학생~실무자 presets,
  editable) that gets baked into the content skeleton and the request
  note sent to Claude Code, instructing it to match vocabulary/depth
  to that audience and fill in a terms glossary per slide.
- generator/build_deck.py: sections/closing can carry a "terms" list;
  both the PPTX and the Reveal.js deck render it as a glossary strip
  pinned to the bottom of the slide. Title slide shows the audience.
- Rewrote the example deck ("Visual Studio를 이용한 나만의 Agent
  만들기") at 중학생 (middle-school) level with glossary terms on
  every slide.
- Rebuilt dist/PT-Agent.exe; the existing desktop shortcut points to
  the same path so it now runs the updated app.

Co-Authored-By: Claude Sonnet 5 <noreply@anthropic.com>
</commit_message>
<xml_diff>
--- a/docs/01-visual-studio-agent/slides.pptx
+++ b/docs/01-visual-studio-agent/slides.pptx
@@ -3176,7 +3176,42 @@
       </p:sp>
       <p:sp>
         <p:nvSpPr>
-          <p:cNvPr id="4" name="Rectangle 3"/>
+          <p:cNvPr id="4" name="TextBox 3"/>
+          <p:cNvSpPr txBox="1"/>
+          <p:nvPr/>
+        </p:nvSpPr>
+        <p:spPr>
+          <a:xfrm>
+            <a:off x="731520" y="4480560"/>
+            <a:ext cx="10698480" cy="548640"/>
+          </a:xfrm>
+          <a:prstGeom prst="rect">
+            <a:avLst/>
+          </a:prstGeom>
+          <a:noFill/>
+        </p:spPr>
+        <p:txBody>
+          <a:bodyPr wrap="none">
+            <a:spAutoFit/>
+          </a:bodyPr>
+          <a:lstStyle/>
+          <a:p>
+            <a:pPr>
+              <a:defRPr sz="1600">
+                <a:solidFill>
+                  <a:srgbClr val="CCD6F6"/>
+                </a:solidFill>
+              </a:defRPr>
+            </a:pPr>
+            <a:r>
+              <a:t>대상: 중학생</a:t>
+            </a:r>
+          </a:p>
+        </p:txBody>
+      </p:sp>
+      <p:sp>
+        <p:nvSpPr>
+          <p:cNvPr id="5" name="Rectangle 4"/>
           <p:cNvSpPr/>
           <p:nvPr/>
         </p:nvSpPr>
@@ -3330,7 +3365,7 @@
         <p:spPr>
           <a:xfrm>
             <a:off x="640080" y="1417320"/>
-            <a:ext cx="10881360" cy="4754880"/>
+            <a:ext cx="10881360" cy="4480560"/>
           </a:xfrm>
           <a:prstGeom prst="rect">
             <a:avLst/>
@@ -3354,7 +3389,7 @@
               </a:defRPr>
             </a:pPr>
             <a:r>
-              <a:t>•  Microsoft가 만든 통합 개발 환경(IDE) — 코드 작성, 디버깅, 테스트, 배포를 한 곳에서 처리</a:t>
+              <a:t>•  Visual Studio는 마이크로소프트(Microsoft)가 만든 프로그램이에요</a:t>
             </a:r>
           </a:p>
           <a:p>
@@ -3369,7 +3404,7 @@
               </a:defRPr>
             </a:pPr>
             <a:r>
-              <a:t>•  C#, C++, Python, JavaScript/TypeScript 등 다양한 언어와 프레임워크 지원</a:t>
+              <a:t>•  한글이나 워드로 글을 쓰듯, 이 프로그램 안에서 '코드'(컴퓨터에게 시키는 명령어)를 써요</a:t>
             </a:r>
           </a:p>
           <a:p>
@@ -3384,7 +3419,7 @@
               </a:defRPr>
             </a:pPr>
             <a:r>
-              <a:t>•  Community(무료) / Professional / Enterprise 에디션 제공</a:t>
+              <a:t>•  코드를 쓰고, 잘못된 부분을 찾아 고치고, 실제로 실행해보는 것까지 한 프로그램에서 다 할 수 있어요</a:t>
             </a:r>
           </a:p>
           <a:p>
@@ -3399,14 +3434,153 @@
               </a:defRPr>
             </a:pPr>
             <a:r>
-              <a:t>•  Visual Studio 2026: '세계 최초의 AI 네이티브 IDE'를 표방하며 Copilot이 핵심 기능으로 완전히 통합</a:t>
-            </a:r>
-          </a:p>
-        </p:txBody>
-      </p:sp>
-      <p:sp>
-        <p:nvSpPr>
-          <p:cNvPr id="5" name="TextBox 4"/>
+              <a:t>•  무료로 쓸 수 있는 버전(Community)이 있어서 학생도 설치해서 바로 써볼 수 있어요</a:t>
+            </a:r>
+          </a:p>
+          <a:p>
+            <a:pPr>
+              <a:spcAft>
+                <a:spcPts val="1200"/>
+              </a:spcAft>
+              <a:defRPr sz="1700">
+                <a:solidFill>
+                  <a:srgbClr val="333A4D"/>
+                </a:solidFill>
+              </a:defRPr>
+            </a:pPr>
+            <a:r>
+              <a:t>•  2026년형 최신 버전은 AI 도우미가 기본으로 들어있어서, 코드를 짤 때 옆에서 같이 도와줘요</a:t>
+            </a:r>
+          </a:p>
+        </p:txBody>
+      </p:sp>
+      <p:sp>
+        <p:nvSpPr>
+          <p:cNvPr id="5" name="Rectangle 4"/>
+          <p:cNvSpPr/>
+          <p:nvPr/>
+        </p:nvSpPr>
+        <p:spPr>
+          <a:xfrm>
+            <a:off x="640080" y="5989320"/>
+            <a:ext cx="10881360" cy="15240"/>
+          </a:xfrm>
+          <a:prstGeom prst="rect">
+            <a:avLst/>
+          </a:prstGeom>
+          <a:solidFill>
+            <a:srgbClr val="D8DCE6"/>
+          </a:solidFill>
+          <a:ln>
+            <a:noFill/>
+          </a:ln>
+        </p:spPr>
+        <p:style>
+          <a:lnRef idx="1">
+            <a:schemeClr val="accent1"/>
+          </a:lnRef>
+          <a:fillRef idx="3">
+            <a:schemeClr val="accent1"/>
+          </a:fillRef>
+          <a:effectRef idx="2">
+            <a:schemeClr val="accent1"/>
+          </a:effectRef>
+          <a:fontRef idx="minor">
+            <a:schemeClr val="lt1"/>
+          </a:fontRef>
+        </p:style>
+        <p:txBody>
+          <a:bodyPr rtlCol="0" anchor="ctr"/>
+          <a:lstStyle/>
+          <a:p>
+            <a:pPr algn="ctr"/>
+          </a:p>
+        </p:txBody>
+      </p:sp>
+      <p:sp>
+        <p:nvSpPr>
+          <p:cNvPr id="6" name="TextBox 5"/>
+          <p:cNvSpPr txBox="1"/>
+          <p:nvPr/>
+        </p:nvSpPr>
+        <p:spPr>
+          <a:xfrm>
+            <a:off x="640080" y="6080760"/>
+            <a:ext cx="10881360" cy="685800"/>
+          </a:xfrm>
+          <a:prstGeom prst="rect">
+            <a:avLst/>
+          </a:prstGeom>
+          <a:noFill/>
+        </p:spPr>
+        <p:txBody>
+          <a:bodyPr wrap="square">
+            <a:spAutoFit/>
+          </a:bodyPr>
+          <a:lstStyle/>
+          <a:p>
+            <a:r>
+              <a:rPr sz="1100" b="1">
+                <a:solidFill>
+                  <a:srgbClr val="4F8CFF"/>
+                </a:solidFill>
+              </a:rPr>
+              <a:t>용어 설명   </a:t>
+            </a:r>
+            <a:r>
+              <a:rPr sz="1100">
+                <a:solidFill>
+                  <a:srgbClr val="333A4D"/>
+                </a:solidFill>
+              </a:rPr>
+              <a:t/>
+            </a:r>
+            <a:r>
+              <a:rPr sz="1100" b="1">
+                <a:solidFill>
+                  <a:srgbClr val="111C3B"/>
+                </a:solidFill>
+              </a:rPr>
+              <a:t>코드(Code) </a:t>
+            </a:r>
+            <a:r>
+              <a:rPr sz="1100">
+                <a:solidFill>
+                  <a:srgbClr val="333A4D"/>
+                </a:solidFill>
+              </a:rPr>
+              <a:t>컴퓨터에게 무엇을 하라고 알려주는 명령어 모음</a:t>
+            </a:r>
+            <a:r>
+              <a:rPr sz="1100">
+                <a:solidFill>
+                  <a:srgbClr val="333A4D"/>
+                </a:solidFill>
+              </a:rPr>
+              <a:t>     ·     </a:t>
+            </a:r>
+            <a:r>
+              <a:rPr sz="1100" b="1">
+                <a:solidFill>
+                  <a:srgbClr val="111C3B"/>
+                </a:solidFill>
+              </a:rPr>
+              <a:t>IDE </a:t>
+            </a:r>
+            <a:r>
+              <a:rPr sz="1100">
+                <a:solidFill>
+                  <a:srgbClr val="333A4D"/>
+                </a:solidFill>
+              </a:rPr>
+              <a:t>코드를 쓰고 실행하고 오류를 찾는 걸 한 프로그램에서 다 할 수 있게 해주는 도구. Visual Studio가 대표적인 IDE예요</a:t>
+            </a:r>
+          </a:p>
+        </p:txBody>
+      </p:sp>
+      <p:sp>
+        <p:nvSpPr>
+          <p:cNvPr id="7" name="TextBox 6"/>
           <p:cNvSpPr txBox="1"/>
           <p:nvPr/>
         </p:nvSpPr>
@@ -3552,7 +3726,7 @@
         <p:spPr>
           <a:xfrm>
             <a:off x="640080" y="1417320"/>
-            <a:ext cx="10881360" cy="4754880"/>
+            <a:ext cx="10881360" cy="4480560"/>
           </a:xfrm>
           <a:prstGeom prst="rect">
             <a:avLst/>
@@ -3576,7 +3750,7 @@
               </a:defRPr>
             </a:pPr>
             <a:r>
-              <a:t>•  지능형 코드 편집 — IntelliSense 자동완성, 리팩터링, 실시간 오류 검사</a:t>
+              <a:t>•  자동 완성 — 코드를 치다 보면 다음에 올 말을 미리 알려줘서 더 빠르게 쓸 수 있어요</a:t>
             </a:r>
           </a:p>
           <a:p>
@@ -3591,7 +3765,7 @@
               </a:defRPr>
             </a:pPr>
             <a:r>
-              <a:t>•  강력한 디버거 — 중단점, 조건부 디버깅, 실시간 변수 확인, 핫 리로드</a:t>
+              <a:t>•  디버깅 — 코드에서 잘못된 부분(버그)을 찾아서 고칠 수 있게 도와줘요</a:t>
             </a:r>
           </a:p>
           <a:p>
@@ -3606,7 +3780,7 @@
               </a:defRPr>
             </a:pPr>
             <a:r>
-              <a:t>•  Git 통합 — 커밋 · 브랜치 · Pull Request를 IDE 안에서 바로 처리</a:t>
+              <a:t>•  Git 연동 — 내가 만든 코드를 저장하고, 예전 버전으로 되돌리는 것도 할 수 있어요</a:t>
             </a:r>
           </a:p>
           <a:p>
@@ -3621,7 +3795,7 @@
               </a:defRPr>
             </a:pPr>
             <a:r>
-              <a:t>•  테스트 러너 &amp; 코드 커버리지 — 2026 버전부터 Community 에디션에서도 기본 제공</a:t>
+              <a:t>•  테스트 기능 — 내가 만든 프로그램이 제대로 작동하는지 자동으로 확인해줘요</a:t>
             </a:r>
           </a:p>
           <a:p>
@@ -3636,7 +3810,7 @@
               </a:defRPr>
             </a:pPr>
             <a:r>
-              <a:t>•  AI 기반 기능 — Copilot 채팅, 코드 생성/설명, 성능 프로파일링 어시스턴트</a:t>
+              <a:t>•  AI 채팅(Copilot) — 궁금한 걸 물어보면 AI가 코드를 대신 써주거나 설명해줘요</a:t>
             </a:r>
           </a:p>
           <a:p>
@@ -3651,7 +3825,7 @@
               </a:defRPr>
             </a:pPr>
             <a:r>
-              <a:t>•  새로운 Fluent UI — 11종 테마와 사용자 지정 색상 토큰으로 가독성 향상</a:t>
+              <a:t>•  다양한 테마 — 눈이 편안한 여러 색 화면 중에서 고를 수 있어요</a:t>
             </a:r>
           </a:p>
           <a:p>
@@ -3666,14 +3840,162 @@
               </a:defRPr>
             </a:pPr>
             <a:r>
-              <a:t>•  확장(Extension) 마켓플레이스로 기능을 자유롭게 추가</a:t>
-            </a:r>
-          </a:p>
-        </p:txBody>
-      </p:sp>
-      <p:sp>
-        <p:nvSpPr>
-          <p:cNvPr id="5" name="TextBox 4"/>
+              <a:t>•  확장 기능 — 스마트폰에 앱을 설치하듯, 필요한 기능을 나중에 더 추가할 수 있어요</a:t>
+            </a:r>
+          </a:p>
+        </p:txBody>
+      </p:sp>
+      <p:sp>
+        <p:nvSpPr>
+          <p:cNvPr id="5" name="Rectangle 4"/>
+          <p:cNvSpPr/>
+          <p:nvPr/>
+        </p:nvSpPr>
+        <p:spPr>
+          <a:xfrm>
+            <a:off x="640080" y="5989320"/>
+            <a:ext cx="10881360" cy="15240"/>
+          </a:xfrm>
+          <a:prstGeom prst="rect">
+            <a:avLst/>
+          </a:prstGeom>
+          <a:solidFill>
+            <a:srgbClr val="D8DCE6"/>
+          </a:solidFill>
+          <a:ln>
+            <a:noFill/>
+          </a:ln>
+        </p:spPr>
+        <p:style>
+          <a:lnRef idx="1">
+            <a:schemeClr val="accent1"/>
+          </a:lnRef>
+          <a:fillRef idx="3">
+            <a:schemeClr val="accent1"/>
+          </a:fillRef>
+          <a:effectRef idx="2">
+            <a:schemeClr val="accent1"/>
+          </a:effectRef>
+          <a:fontRef idx="minor">
+            <a:schemeClr val="lt1"/>
+          </a:fontRef>
+        </p:style>
+        <p:txBody>
+          <a:bodyPr rtlCol="0" anchor="ctr"/>
+          <a:lstStyle/>
+          <a:p>
+            <a:pPr algn="ctr"/>
+          </a:p>
+        </p:txBody>
+      </p:sp>
+      <p:sp>
+        <p:nvSpPr>
+          <p:cNvPr id="6" name="TextBox 5"/>
+          <p:cNvSpPr txBox="1"/>
+          <p:nvPr/>
+        </p:nvSpPr>
+        <p:spPr>
+          <a:xfrm>
+            <a:off x="640080" y="6080760"/>
+            <a:ext cx="10881360" cy="685800"/>
+          </a:xfrm>
+          <a:prstGeom prst="rect">
+            <a:avLst/>
+          </a:prstGeom>
+          <a:noFill/>
+        </p:spPr>
+        <p:txBody>
+          <a:bodyPr wrap="square">
+            <a:spAutoFit/>
+          </a:bodyPr>
+          <a:lstStyle/>
+          <a:p>
+            <a:r>
+              <a:rPr sz="1100" b="1">
+                <a:solidFill>
+                  <a:srgbClr val="4F8CFF"/>
+                </a:solidFill>
+              </a:rPr>
+              <a:t>용어 설명   </a:t>
+            </a:r>
+            <a:r>
+              <a:rPr sz="1100">
+                <a:solidFill>
+                  <a:srgbClr val="333A4D"/>
+                </a:solidFill>
+              </a:rPr>
+              <a:t/>
+            </a:r>
+            <a:r>
+              <a:rPr sz="1100" b="1">
+                <a:solidFill>
+                  <a:srgbClr val="111C3B"/>
+                </a:solidFill>
+              </a:rPr>
+              <a:t>버그(Bug) </a:t>
+            </a:r>
+            <a:r>
+              <a:rPr sz="1100">
+                <a:solidFill>
+                  <a:srgbClr val="333A4D"/>
+                </a:solidFill>
+              </a:rPr>
+              <a:t>프로그램에서 잘못 작동하는 부분</a:t>
+            </a:r>
+            <a:r>
+              <a:rPr sz="1100">
+                <a:solidFill>
+                  <a:srgbClr val="333A4D"/>
+                </a:solidFill>
+              </a:rPr>
+              <a:t>     ·     </a:t>
+            </a:r>
+            <a:r>
+              <a:rPr sz="1100" b="1">
+                <a:solidFill>
+                  <a:srgbClr val="111C3B"/>
+                </a:solidFill>
+              </a:rPr>
+              <a:t>디버깅 </a:t>
+            </a:r>
+            <a:r>
+              <a:rPr sz="1100">
+                <a:solidFill>
+                  <a:srgbClr val="333A4D"/>
+                </a:solidFill>
+              </a:rPr>
+              <a:t>버그를 찾아서 고치는 작업</a:t>
+            </a:r>
+            <a:r>
+              <a:rPr sz="1100">
+                <a:solidFill>
+                  <a:srgbClr val="333A4D"/>
+                </a:solidFill>
+              </a:rPr>
+              <a:t>     ·     </a:t>
+            </a:r>
+            <a:r>
+              <a:rPr sz="1100" b="1">
+                <a:solidFill>
+                  <a:srgbClr val="111C3B"/>
+                </a:solidFill>
+              </a:rPr>
+              <a:t>Git </a:t>
+            </a:r>
+            <a:r>
+              <a:rPr sz="1100">
+                <a:solidFill>
+                  <a:srgbClr val="333A4D"/>
+                </a:solidFill>
+              </a:rPr>
+              <a:t>코드를 저장하고 여러 버전을 관리해주는 도구</a:t>
+            </a:r>
+          </a:p>
+        </p:txBody>
+      </p:sp>
+      <p:sp>
+        <p:nvSpPr>
+          <p:cNvPr id="7" name="TextBox 6"/>
           <p:cNvSpPr txBox="1"/>
           <p:nvPr/>
         </p:nvSpPr>
@@ -3819,7 +4141,7 @@
         <p:spPr>
           <a:xfrm>
             <a:off x="640080" y="1417320"/>
-            <a:ext cx="6400800" cy="4754880"/>
+            <a:ext cx="6400800" cy="4480560"/>
           </a:xfrm>
           <a:prstGeom prst="rect">
             <a:avLst/>
@@ -3843,7 +4165,7 @@
               </a:defRPr>
             </a:pPr>
             <a:r>
-              <a:t>•  JavaScript Object Notation의 약자 — 사람이 읽고 쓰기 쉬운 경량 데이터 교환 포맷</a:t>
+              <a:t>•  JSON은 컴퓨터끼리 정보를 주고받을 때 자주 쓰는 '간단한 메모 형식'이에요</a:t>
             </a:r>
           </a:p>
           <a:p>
@@ -3858,7 +4180,7 @@
               </a:defRPr>
             </a:pPr>
             <a:r>
-              <a:t>•  key-value 쌍과 배열([ ])로 이루어진 트리 구조</a:t>
+              <a:t>•  예를 들어 '이름: 홍길동, 나이: 14'처럼 이름표와 내용을 짝지어 적어요</a:t>
             </a:r>
           </a:p>
           <a:p>
@@ -3873,7 +4195,7 @@
               </a:defRPr>
             </a:pPr>
             <a:r>
-              <a:t>•  프로그래밍 언어에 독립적 — 대부분의 언어가 파서를 기본 제공</a:t>
+              <a:t>•  사람이 읽기도 쉽고, 어떤 프로그래밍 언어에서도 쉽게 사용할 수 있어요</a:t>
             </a:r>
           </a:p>
           <a:p>
@@ -3888,7 +4210,7 @@
               </a:defRPr>
             </a:pPr>
             <a:r>
-              <a:t>•  웹 API 응답, 설정 파일(package.json 등), 앱 간 데이터 교환에 널리 사용</a:t>
+              <a:t>•  웹사이트에서 정보를 받아올 때나, 프로그램 설정을 저장할 때 자주 사용해요</a:t>
             </a:r>
           </a:p>
           <a:p>
@@ -3903,7 +4225,7 @@
               </a:defRPr>
             </a:pPr>
             <a:r>
-              <a:t>•  Visual Studio · Claude Code에서도 MCP 서버 설정, launch.json, settings.json 등에 JSON을 사용</a:t>
+              <a:t>•  Visual Studio와 Claude Code도 설정 파일을 이 JSON 형식으로 만들어요</a:t>
             </a:r>
           </a:p>
         </p:txBody>
@@ -3987,7 +4309,131 @@
       </p:sp>
       <p:sp>
         <p:nvSpPr>
-          <p:cNvPr id="6" name="TextBox 5"/>
+          <p:cNvPr id="6" name="Rectangle 5"/>
+          <p:cNvSpPr/>
+          <p:nvPr/>
+        </p:nvSpPr>
+        <p:spPr>
+          <a:xfrm>
+            <a:off x="640080" y="5989320"/>
+            <a:ext cx="10881360" cy="15240"/>
+          </a:xfrm>
+          <a:prstGeom prst="rect">
+            <a:avLst/>
+          </a:prstGeom>
+          <a:solidFill>
+            <a:srgbClr val="D8DCE6"/>
+          </a:solidFill>
+          <a:ln>
+            <a:noFill/>
+          </a:ln>
+        </p:spPr>
+        <p:style>
+          <a:lnRef idx="1">
+            <a:schemeClr val="accent1"/>
+          </a:lnRef>
+          <a:fillRef idx="3">
+            <a:schemeClr val="accent1"/>
+          </a:fillRef>
+          <a:effectRef idx="2">
+            <a:schemeClr val="accent1"/>
+          </a:effectRef>
+          <a:fontRef idx="minor">
+            <a:schemeClr val="lt1"/>
+          </a:fontRef>
+        </p:style>
+        <p:txBody>
+          <a:bodyPr rtlCol="0" anchor="ctr"/>
+          <a:lstStyle/>
+          <a:p>
+            <a:pPr algn="ctr"/>
+          </a:p>
+        </p:txBody>
+      </p:sp>
+      <p:sp>
+        <p:nvSpPr>
+          <p:cNvPr id="7" name="TextBox 6"/>
+          <p:cNvSpPr txBox="1"/>
+          <p:nvPr/>
+        </p:nvSpPr>
+        <p:spPr>
+          <a:xfrm>
+            <a:off x="640080" y="6080760"/>
+            <a:ext cx="10881360" cy="685800"/>
+          </a:xfrm>
+          <a:prstGeom prst="rect">
+            <a:avLst/>
+          </a:prstGeom>
+          <a:noFill/>
+        </p:spPr>
+        <p:txBody>
+          <a:bodyPr wrap="square">
+            <a:spAutoFit/>
+          </a:bodyPr>
+          <a:lstStyle/>
+          <a:p>
+            <a:r>
+              <a:rPr sz="1100" b="1">
+                <a:solidFill>
+                  <a:srgbClr val="4F8CFF"/>
+                </a:solidFill>
+              </a:rPr>
+              <a:t>용어 설명   </a:t>
+            </a:r>
+            <a:r>
+              <a:rPr sz="1100">
+                <a:solidFill>
+                  <a:srgbClr val="333A4D"/>
+                </a:solidFill>
+              </a:rPr>
+              <a:t/>
+            </a:r>
+            <a:r>
+              <a:rPr sz="1100" b="1">
+                <a:solidFill>
+                  <a:srgbClr val="111C3B"/>
+                </a:solidFill>
+              </a:rPr>
+              <a:t>이름표-내용(Key-Value) </a:t>
+            </a:r>
+            <a:r>
+              <a:rPr sz="1100">
+                <a:solidFill>
+                  <a:srgbClr val="333A4D"/>
+                </a:solidFill>
+              </a:rPr>
+              <a:t>'이름표: 내용'처럼 한 쌍으로 짝지어 정보를 적는 방식</a:t>
+            </a:r>
+            <a:r>
+              <a:rPr sz="1100">
+                <a:solidFill>
+                  <a:srgbClr val="333A4D"/>
+                </a:solidFill>
+              </a:rPr>
+              <a:t>     ·     </a:t>
+            </a:r>
+            <a:r>
+              <a:rPr sz="1100" b="1">
+                <a:solidFill>
+                  <a:srgbClr val="111C3B"/>
+                </a:solidFill>
+              </a:rPr>
+              <a:t>설정 파일 </a:t>
+            </a:r>
+            <a:r>
+              <a:rPr sz="1100">
+                <a:solidFill>
+                  <a:srgbClr val="333A4D"/>
+                </a:solidFill>
+              </a:rPr>
+              <a:t>프로그램이 어떻게 동작할지 미리 정해놓은 파일</a:t>
+            </a:r>
+          </a:p>
+        </p:txBody>
+      </p:sp>
+      <p:sp>
+        <p:nvSpPr>
+          <p:cNvPr id="8" name="TextBox 7"/>
           <p:cNvSpPr txBox="1"/>
           <p:nvPr/>
         </p:nvSpPr>
@@ -4133,7 +4579,7 @@
         <p:spPr>
           <a:xfrm>
             <a:off x="640080" y="1417320"/>
-            <a:ext cx="10881360" cy="4754880"/>
+            <a:ext cx="10881360" cy="4480560"/>
           </a:xfrm>
           <a:prstGeom prst="rect">
             <a:avLst/>
@@ -4157,7 +4603,7 @@
               </a:defRPr>
             </a:pPr>
             <a:r>
-              <a:t>•  Anthropic이 만든 터미널/에디터 기반 AI 코딩 에이전트(CLI)</a:t>
+              <a:t>•  Claude Code는 Anthropic이라는 회사가 만든, 대화로 코드를 작성해주는 AI 프로그램이에요</a:t>
             </a:r>
           </a:p>
           <a:p>
@@ -4172,7 +4618,7 @@
               </a:defRPr>
             </a:pPr>
             <a:r>
-              <a:t>•  전체 코드베이스를 이해하고 여러 파일을 한 번에 읽고 수정</a:t>
+              <a:t>•  사람이 '이런 기능 만들어줘'라고 말하면, AI가 알아서 코드를 쓰고 고쳐줘요</a:t>
             </a:r>
           </a:p>
           <a:p>
@@ -4187,7 +4633,7 @@
               </a:defRPr>
             </a:pPr>
             <a:r>
-              <a:t>•  자연어 지시만으로 기능 구현, 버그 수정, 테스트 작성, git 커밋/PR까지 자동 수행</a:t>
+              <a:t>•  여러 개의 파일을 한 번에 보고 이해해서, 큰 프로그램도 함께 도와줄 수 있어요</a:t>
             </a:r>
           </a:p>
           <a:p>
@@ -4202,7 +4648,7 @@
               </a:defRPr>
             </a:pPr>
             <a:r>
-              <a:t>•  CLAUDE.md · Skills · Subagents · Slash Commands · Hooks · MCP 서버로 자유롭게 확장</a:t>
+              <a:t>•  실행하기 전에 '이렇게 할게요'라는 계획을 먼저 보여주고, 확인한 다음 진행할 수 있어요</a:t>
             </a:r>
           </a:p>
           <a:p>
@@ -4217,29 +4663,138 @@
               </a:defRPr>
             </a:pPr>
             <a:r>
-              <a:t>•  Plan Mode — 실행 전에 계획을 먼저 검토하고 수정 가능</a:t>
-            </a:r>
-          </a:p>
-          <a:p>
-            <a:pPr>
-              <a:spcAft>
-                <a:spcPts val="1200"/>
-              </a:spcAft>
-              <a:defRPr sz="1700">
-                <a:solidFill>
-                  <a:srgbClr val="333A4D"/>
-                </a:solidFill>
-              </a:defRPr>
-            </a:pPr>
-            <a:r>
-              <a:t>•  VS Code, Visual Studio, JetBrains 등 주요 IDE와 통합 지원</a:t>
-            </a:r>
-          </a:p>
-        </p:txBody>
-      </p:sp>
-      <p:sp>
-        <p:nvSpPr>
-          <p:cNvPr id="5" name="TextBox 4"/>
+              <a:t>•  Visual Studio 같은 프로그램 안에서 함께 사용할 수 있어요</a:t>
+            </a:r>
+          </a:p>
+        </p:txBody>
+      </p:sp>
+      <p:sp>
+        <p:nvSpPr>
+          <p:cNvPr id="5" name="Rectangle 4"/>
+          <p:cNvSpPr/>
+          <p:nvPr/>
+        </p:nvSpPr>
+        <p:spPr>
+          <a:xfrm>
+            <a:off x="640080" y="5989320"/>
+            <a:ext cx="10881360" cy="15240"/>
+          </a:xfrm>
+          <a:prstGeom prst="rect">
+            <a:avLst/>
+          </a:prstGeom>
+          <a:solidFill>
+            <a:srgbClr val="D8DCE6"/>
+          </a:solidFill>
+          <a:ln>
+            <a:noFill/>
+          </a:ln>
+        </p:spPr>
+        <p:style>
+          <a:lnRef idx="1">
+            <a:schemeClr val="accent1"/>
+          </a:lnRef>
+          <a:fillRef idx="3">
+            <a:schemeClr val="accent1"/>
+          </a:fillRef>
+          <a:effectRef idx="2">
+            <a:schemeClr val="accent1"/>
+          </a:effectRef>
+          <a:fontRef idx="minor">
+            <a:schemeClr val="lt1"/>
+          </a:fontRef>
+        </p:style>
+        <p:txBody>
+          <a:bodyPr rtlCol="0" anchor="ctr"/>
+          <a:lstStyle/>
+          <a:p>
+            <a:pPr algn="ctr"/>
+          </a:p>
+        </p:txBody>
+      </p:sp>
+      <p:sp>
+        <p:nvSpPr>
+          <p:cNvPr id="6" name="TextBox 5"/>
+          <p:cNvSpPr txBox="1"/>
+          <p:nvPr/>
+        </p:nvSpPr>
+        <p:spPr>
+          <a:xfrm>
+            <a:off x="640080" y="6080760"/>
+            <a:ext cx="10881360" cy="685800"/>
+          </a:xfrm>
+          <a:prstGeom prst="rect">
+            <a:avLst/>
+          </a:prstGeom>
+          <a:noFill/>
+        </p:spPr>
+        <p:txBody>
+          <a:bodyPr wrap="square">
+            <a:spAutoFit/>
+          </a:bodyPr>
+          <a:lstStyle/>
+          <a:p>
+            <a:r>
+              <a:rPr sz="1100" b="1">
+                <a:solidFill>
+                  <a:srgbClr val="4F8CFF"/>
+                </a:solidFill>
+              </a:rPr>
+              <a:t>용어 설명   </a:t>
+            </a:r>
+            <a:r>
+              <a:rPr sz="1100">
+                <a:solidFill>
+                  <a:srgbClr val="333A4D"/>
+                </a:solidFill>
+              </a:rPr>
+              <a:t/>
+            </a:r>
+            <a:r>
+              <a:rPr sz="1100" b="1">
+                <a:solidFill>
+                  <a:srgbClr val="111C3B"/>
+                </a:solidFill>
+              </a:rPr>
+              <a:t>AI 에이전트 </a:t>
+            </a:r>
+            <a:r>
+              <a:rPr sz="1100">
+                <a:solidFill>
+                  <a:srgbClr val="333A4D"/>
+                </a:solidFill>
+              </a:rPr>
+              <a:t>스스로 판단해서 여러 작업을 척척 해내는 AI 프로그램</a:t>
+            </a:r>
+            <a:r>
+              <a:rPr sz="1100">
+                <a:solidFill>
+                  <a:srgbClr val="333A4D"/>
+                </a:solidFill>
+              </a:rPr>
+              <a:t>     ·     </a:t>
+            </a:r>
+            <a:r>
+              <a:rPr sz="1100" b="1">
+                <a:solidFill>
+                  <a:srgbClr val="111C3B"/>
+                </a:solidFill>
+              </a:rPr>
+              <a:t>Plan Mode </a:t>
+            </a:r>
+            <a:r>
+              <a:rPr sz="1100">
+                <a:solidFill>
+                  <a:srgbClr val="333A4D"/>
+                </a:solidFill>
+              </a:rPr>
+              <a:t>AI가 작업을 하기 전에 계획을 먼저 보여주는 기능</a:t>
+            </a:r>
+          </a:p>
+        </p:txBody>
+      </p:sp>
+      <p:sp>
+        <p:nvSpPr>
+          <p:cNvPr id="7" name="TextBox 6"/>
           <p:cNvSpPr txBox="1"/>
           <p:nvPr/>
         </p:nvSpPr>
@@ -4385,7 +4940,7 @@
         <p:spPr>
           <a:xfrm>
             <a:off x="640080" y="1417320"/>
-            <a:ext cx="10881360" cy="4754880"/>
+            <a:ext cx="10881360" cy="4480560"/>
           </a:xfrm>
           <a:prstGeom prst="rect">
             <a:avLst/>
@@ -4409,7 +4964,7 @@
               </a:defRPr>
             </a:pPr>
             <a:r>
-              <a:t>•  방법 1 — 확장 설치 후 사이드바(Spark 아이콘)에서 Claude Code 패널 열기</a:t>
+              <a:t>•  방법 1 — Visual Studio(또는 VS Code)에 Claude Code 확장 프로그램을 설치해요</a:t>
             </a:r>
           </a:p>
           <a:p>
@@ -4424,7 +4979,7 @@
               </a:defRPr>
             </a:pPr>
             <a:r>
-              <a:t>•  방법 2 — 통합 터미널에서 claude 명령 실행 → IDE 환경을 자동 감지해 연동</a:t>
+              <a:t>•  방법 2 — 프로그램 안의 '터미널'에 claude 라고 입력하면 바로 연결돼요</a:t>
             </a:r>
           </a:p>
           <a:p>
@@ -4439,7 +4994,7 @@
               </a:defRPr>
             </a:pPr>
             <a:r>
-              <a:t>•  파일/코드 범위를 @멘션으로 지정해 정확한 위치를 수정 요청</a:t>
+              <a:t>•  '이 파일을 고쳐줘'처럼 원하는 부분을 콕 집어서 요청할 수 있어요</a:t>
             </a:r>
           </a:p>
           <a:p>
@@ -4454,7 +5009,7 @@
               </a:defRPr>
             </a:pPr>
             <a:r>
-              <a:t>•  변경 사항은 에디터 Diff 뷰로 확인한 뒤 승인 또는 수정</a:t>
+              <a:t>•  AI가 고친 부분은 색깔로 표시돼서, 확인하고 승인할 수 있어요</a:t>
             </a:r>
           </a:p>
           <a:p>
@@ -4469,7 +5024,7 @@
               </a:defRPr>
             </a:pPr>
             <a:r>
-              <a:t>•  복잡한 작업은 Plan Mode로 계획을 먼저 세우고 승인 후 실행</a:t>
+              <a:t>•  복잡한 작업은 계획을 먼저 세우고 나서 진행해요</a:t>
             </a:r>
           </a:p>
           <a:p>
@@ -4484,14 +5039,138 @@
               </a:defRPr>
             </a:pPr>
             <a:r>
-              <a:t>•  CLAUDE.md에 프로젝트 규칙을 적어두면 매번 같은 설명을 반복할 필요 없음</a:t>
-            </a:r>
-          </a:p>
-        </p:txBody>
-      </p:sp>
-      <p:sp>
-        <p:nvSpPr>
-          <p:cNvPr id="5" name="TextBox 4"/>
+              <a:t>•  자주 쓰는 규칙을 한 번 적어두면, 매번 설명하지 않아도 AI가 기억해줘요</a:t>
+            </a:r>
+          </a:p>
+        </p:txBody>
+      </p:sp>
+      <p:sp>
+        <p:nvSpPr>
+          <p:cNvPr id="5" name="Rectangle 4"/>
+          <p:cNvSpPr/>
+          <p:nvPr/>
+        </p:nvSpPr>
+        <p:spPr>
+          <a:xfrm>
+            <a:off x="640080" y="5989320"/>
+            <a:ext cx="10881360" cy="15240"/>
+          </a:xfrm>
+          <a:prstGeom prst="rect">
+            <a:avLst/>
+          </a:prstGeom>
+          <a:solidFill>
+            <a:srgbClr val="D8DCE6"/>
+          </a:solidFill>
+          <a:ln>
+            <a:noFill/>
+          </a:ln>
+        </p:spPr>
+        <p:style>
+          <a:lnRef idx="1">
+            <a:schemeClr val="accent1"/>
+          </a:lnRef>
+          <a:fillRef idx="3">
+            <a:schemeClr val="accent1"/>
+          </a:fillRef>
+          <a:effectRef idx="2">
+            <a:schemeClr val="accent1"/>
+          </a:effectRef>
+          <a:fontRef idx="minor">
+            <a:schemeClr val="lt1"/>
+          </a:fontRef>
+        </p:style>
+        <p:txBody>
+          <a:bodyPr rtlCol="0" anchor="ctr"/>
+          <a:lstStyle/>
+          <a:p>
+            <a:pPr algn="ctr"/>
+          </a:p>
+        </p:txBody>
+      </p:sp>
+      <p:sp>
+        <p:nvSpPr>
+          <p:cNvPr id="6" name="TextBox 5"/>
+          <p:cNvSpPr txBox="1"/>
+          <p:nvPr/>
+        </p:nvSpPr>
+        <p:spPr>
+          <a:xfrm>
+            <a:off x="640080" y="6080760"/>
+            <a:ext cx="10881360" cy="685800"/>
+          </a:xfrm>
+          <a:prstGeom prst="rect">
+            <a:avLst/>
+          </a:prstGeom>
+          <a:noFill/>
+        </p:spPr>
+        <p:txBody>
+          <a:bodyPr wrap="square">
+            <a:spAutoFit/>
+          </a:bodyPr>
+          <a:lstStyle/>
+          <a:p>
+            <a:r>
+              <a:rPr sz="1100" b="1">
+                <a:solidFill>
+                  <a:srgbClr val="4F8CFF"/>
+                </a:solidFill>
+              </a:rPr>
+              <a:t>용어 설명   </a:t>
+            </a:r>
+            <a:r>
+              <a:rPr sz="1100">
+                <a:solidFill>
+                  <a:srgbClr val="333A4D"/>
+                </a:solidFill>
+              </a:rPr>
+              <a:t/>
+            </a:r>
+            <a:r>
+              <a:rPr sz="1100" b="1">
+                <a:solidFill>
+                  <a:srgbClr val="111C3B"/>
+                </a:solidFill>
+              </a:rPr>
+              <a:t>터미널 </a:t>
+            </a:r>
+            <a:r>
+              <a:rPr sz="1100">
+                <a:solidFill>
+                  <a:srgbClr val="333A4D"/>
+                </a:solidFill>
+              </a:rPr>
+              <a:t>글자로 명령어를 입력해서 컴퓨터에게 일을 시키는 화면</a:t>
+            </a:r>
+            <a:r>
+              <a:rPr sz="1100">
+                <a:solidFill>
+                  <a:srgbClr val="333A4D"/>
+                </a:solidFill>
+              </a:rPr>
+              <a:t>     ·     </a:t>
+            </a:r>
+            <a:r>
+              <a:rPr sz="1100" b="1">
+                <a:solidFill>
+                  <a:srgbClr val="111C3B"/>
+                </a:solidFill>
+              </a:rPr>
+              <a:t>확장 프로그램 </a:t>
+            </a:r>
+            <a:r>
+              <a:rPr sz="1100">
+                <a:solidFill>
+                  <a:srgbClr val="333A4D"/>
+                </a:solidFill>
+              </a:rPr>
+              <a:t>원래 프로그램에 새 기능을 더해주는 부가 프로그램</a:t>
+            </a:r>
+          </a:p>
+        </p:txBody>
+      </p:sp>
+      <p:sp>
+        <p:nvSpPr>
+          <p:cNvPr id="7" name="TextBox 6"/>
           <p:cNvSpPr txBox="1"/>
           <p:nvPr/>
         </p:nvSpPr>
@@ -4637,7 +5316,7 @@
         <p:spPr>
           <a:xfrm>
             <a:off x="640080" y="1417320"/>
-            <a:ext cx="10881360" cy="4754880"/>
+            <a:ext cx="10881360" cy="4480560"/>
           </a:xfrm>
           <a:prstGeom prst="rect">
             <a:avLst/>
@@ -4661,7 +5340,7 @@
               </a:defRPr>
             </a:pPr>
             <a:r>
-              <a:t>•  GitHub — Git 기반 코드 저장 · 협업 플랫폼 (이슈, PR, 코드 리뷰, 프로젝트 관리)</a:t>
+              <a:t>•  GitHub는 내가 만든 코드를 인터넷에 저장하고, 다른 사람과 함께 만들 수 있는 사이트예요</a:t>
             </a:r>
           </a:p>
           <a:p>
@@ -4676,7 +5355,7 @@
               </a:defRPr>
             </a:pPr>
             <a:r>
-              <a:t>•  GitHub Pages — 정적 웹사이트를 무료로 호스팅(Public repo 기준), *.github.io 도메인 기본 제공</a:t>
+              <a:t>•  GitHub Pages — 내가 만든 웹페이지를 무료로 인터넷에 올려서 누구나 볼 수 있게 해줘요</a:t>
             </a:r>
           </a:p>
           <a:p>
@@ -4691,7 +5370,7 @@
               </a:defRPr>
             </a:pPr>
             <a:r>
-              <a:t>•  GitHub Actions — push/PR 등 이벤트에 반응해 빌드 · 테스트 · 배포를 자동화하는 무료 CI/CD</a:t>
+              <a:t>•  GitHub Actions — '코드를 올리면 자동으로 이 작업을 해줘'처럼, 반복되는 일을 자동으로 처리해줘요</a:t>
             </a:r>
           </a:p>
           <a:p>
@@ -4706,7 +5385,7 @@
               </a:defRPr>
             </a:pPr>
             <a:r>
-              <a:t>•  GitHub REST / GraphQL API — 저장소, 이슈, PR 등을 코드로 자동 제어</a:t>
+              <a:t>•  API — 다른 프로그램(예: 카카오톡)과 정보를 주고받을 수 있게 해주는 통로예요</a:t>
             </a:r>
           </a:p>
           <a:p>
@@ -4721,29 +5400,162 @@
               </a:defRPr>
             </a:pPr>
             <a:r>
-              <a:t>•  GitHub CLI(gh) — 터미널에서 저장소 생성, PR, 이슈 등을 명령어로 처리</a:t>
-            </a:r>
-          </a:p>
-          <a:p>
-            <a:pPr>
-              <a:spcAft>
-                <a:spcPts val="1200"/>
-              </a:spcAft>
-              <a:defRPr sz="1700">
-                <a:solidFill>
-                  <a:srgbClr val="333A4D"/>
-                </a:solidFill>
-              </a:defRPr>
-            </a:pPr>
-            <a:r>
-              <a:t>•  그 외 커뮤니티가 정리한 무료 공개 API 모음(Free-APIs 등)도 함께 활용 가능</a:t>
-            </a:r>
-          </a:p>
-        </p:txBody>
-      </p:sp>
-      <p:sp>
-        <p:nvSpPr>
-          <p:cNvPr id="5" name="TextBox 4"/>
+              <a:t>•  gh(깃허브 CLI) — 마우스 없이 글자 명령만으로 깃허브를 다룰 수 있는 도구예요</a:t>
+            </a:r>
+          </a:p>
+        </p:txBody>
+      </p:sp>
+      <p:sp>
+        <p:nvSpPr>
+          <p:cNvPr id="5" name="Rectangle 4"/>
+          <p:cNvSpPr/>
+          <p:nvPr/>
+        </p:nvSpPr>
+        <p:spPr>
+          <a:xfrm>
+            <a:off x="640080" y="5989320"/>
+            <a:ext cx="10881360" cy="15240"/>
+          </a:xfrm>
+          <a:prstGeom prst="rect">
+            <a:avLst/>
+          </a:prstGeom>
+          <a:solidFill>
+            <a:srgbClr val="D8DCE6"/>
+          </a:solidFill>
+          <a:ln>
+            <a:noFill/>
+          </a:ln>
+        </p:spPr>
+        <p:style>
+          <a:lnRef idx="1">
+            <a:schemeClr val="accent1"/>
+          </a:lnRef>
+          <a:fillRef idx="3">
+            <a:schemeClr val="accent1"/>
+          </a:fillRef>
+          <a:effectRef idx="2">
+            <a:schemeClr val="accent1"/>
+          </a:effectRef>
+          <a:fontRef idx="minor">
+            <a:schemeClr val="lt1"/>
+          </a:fontRef>
+        </p:style>
+        <p:txBody>
+          <a:bodyPr rtlCol="0" anchor="ctr"/>
+          <a:lstStyle/>
+          <a:p>
+            <a:pPr algn="ctr"/>
+          </a:p>
+        </p:txBody>
+      </p:sp>
+      <p:sp>
+        <p:nvSpPr>
+          <p:cNvPr id="6" name="TextBox 5"/>
+          <p:cNvSpPr txBox="1"/>
+          <p:nvPr/>
+        </p:nvSpPr>
+        <p:spPr>
+          <a:xfrm>
+            <a:off x="640080" y="6080760"/>
+            <a:ext cx="10881360" cy="685800"/>
+          </a:xfrm>
+          <a:prstGeom prst="rect">
+            <a:avLst/>
+          </a:prstGeom>
+          <a:noFill/>
+        </p:spPr>
+        <p:txBody>
+          <a:bodyPr wrap="square">
+            <a:spAutoFit/>
+          </a:bodyPr>
+          <a:lstStyle/>
+          <a:p>
+            <a:r>
+              <a:rPr sz="1100" b="1">
+                <a:solidFill>
+                  <a:srgbClr val="4F8CFF"/>
+                </a:solidFill>
+              </a:rPr>
+              <a:t>용어 설명   </a:t>
+            </a:r>
+            <a:r>
+              <a:rPr sz="1100">
+                <a:solidFill>
+                  <a:srgbClr val="333A4D"/>
+                </a:solidFill>
+              </a:rPr>
+              <a:t/>
+            </a:r>
+            <a:r>
+              <a:rPr sz="1100" b="1">
+                <a:solidFill>
+                  <a:srgbClr val="111C3B"/>
+                </a:solidFill>
+              </a:rPr>
+              <a:t>저장소(Repository) </a:t>
+            </a:r>
+            <a:r>
+              <a:rPr sz="1100">
+                <a:solidFill>
+                  <a:srgbClr val="333A4D"/>
+                </a:solidFill>
+              </a:rPr>
+              <a:t>코드와 파일들을 모아두는 폴더 같은 공간</a:t>
+            </a:r>
+            <a:r>
+              <a:rPr sz="1100">
+                <a:solidFill>
+                  <a:srgbClr val="333A4D"/>
+                </a:solidFill>
+              </a:rPr>
+              <a:t>     ·     </a:t>
+            </a:r>
+            <a:r>
+              <a:rPr sz="1100" b="1">
+                <a:solidFill>
+                  <a:srgbClr val="111C3B"/>
+                </a:solidFill>
+              </a:rPr>
+              <a:t>API </a:t>
+            </a:r>
+            <a:r>
+              <a:rPr sz="1100">
+                <a:solidFill>
+                  <a:srgbClr val="333A4D"/>
+                </a:solidFill>
+              </a:rPr>
+              <a:t>서로 다른 프로그램이 정보를 주고받을 수 있게 해주는 규칙과 통로</a:t>
+            </a:r>
+            <a:r>
+              <a:rPr sz="1100">
+                <a:solidFill>
+                  <a:srgbClr val="333A4D"/>
+                </a:solidFill>
+              </a:rPr>
+              <a:t>     ·     </a:t>
+            </a:r>
+            <a:r>
+              <a:rPr sz="1100" b="1">
+                <a:solidFill>
+                  <a:srgbClr val="111C3B"/>
+                </a:solidFill>
+              </a:rPr>
+              <a:t>자동화 </a:t>
+            </a:r>
+            <a:r>
+              <a:rPr sz="1100">
+                <a:solidFill>
+                  <a:srgbClr val="333A4D"/>
+                </a:solidFill>
+              </a:rPr>
+              <a:t>사람이 매번 하지 않아도 컴퓨터가 알아서 반복 작업을 해주는 것</a:t>
+            </a:r>
+          </a:p>
+        </p:txBody>
+      </p:sp>
+      <p:sp>
+        <p:nvSpPr>
+          <p:cNvPr id="7" name="TextBox 6"/>
           <p:cNvSpPr txBox="1"/>
           <p:nvPr/>
         </p:nvSpPr>
@@ -4889,7 +5701,7 @@
         <p:spPr>
           <a:xfrm>
             <a:off x="640080" y="1417320"/>
-            <a:ext cx="10881360" cy="4754880"/>
+            <a:ext cx="10881360" cy="4480560"/>
           </a:xfrm>
           <a:prstGeom prst="rect">
             <a:avLst/>
@@ -4913,7 +5725,7 @@
               </a:defRPr>
             </a:pPr>
             <a:r>
-              <a:t>•  목표 — 매일 새로운 영어회화 문장을 자동 생성 → 웹페이지로 게시 → 카카오톡으로 알림</a:t>
+              <a:t>•  목표 — 매일 새로운 영어 회화 문장을 자동으로 만들어서 웹페이지에 올리고, 카카오톡으로 알려주기</a:t>
             </a:r>
           </a:p>
           <a:p>
@@ -4928,7 +5740,7 @@
               </a:defRPr>
             </a:pPr>
             <a:r>
-              <a:t>•  ① Claude Code + GitHub Actions 스케줄(cron)이 매일 영어회화 문장 · 해석 · 예문을 자동 생성</a:t>
+              <a:t>•  ① Claude Code와 GitHub Actions가 매일 정해진 시간에 영어 문장과 뜻을 자동으로 만들어요</a:t>
             </a:r>
           </a:p>
           <a:p>
@@ -4943,7 +5755,7 @@
               </a:defRPr>
             </a:pPr>
             <a:r>
-              <a:t>•  ② 생성된 콘텐츠를 HTML로 저장하고 GitHub Pages에 자동 배포</a:t>
+              <a:t>•  ② 만들어진 내용을 웹페이지(HTML)로 저장해서 GitHub Pages에 자동으로 올려요</a:t>
             </a:r>
           </a:p>
           <a:p>
@@ -4958,7 +5770,7 @@
               </a:defRPr>
             </a:pPr>
             <a:r>
-              <a:t>•  ③ 카카오 디벨로퍼스 REST API의 '나에게 보내기'로 오늘의 웹페이지 링크를 카카오톡으로 전송</a:t>
+              <a:t>•  ③ 카카오톡 API를 이용해서, 완성된 웹페이지 주소를 내 카카오톡으로 보내줘요</a:t>
             </a:r>
           </a:p>
           <a:p>
@@ -4973,7 +5785,7 @@
               </a:defRPr>
             </a:pPr>
             <a:r>
-              <a:t>•  필요한 준비물 — GitHub 저장소 + Actions, 카카오 디벨로퍼스 앱 등록, REST API 키 · Access Token</a:t>
+              <a:t>•  준비물 — GitHub 계정과 저장소, 카카오 개발자 사이트에서 발급받은 열쇠(API 키)</a:t>
             </a:r>
           </a:p>
           <a:p>
@@ -4988,14 +5800,138 @@
               </a:defRPr>
             </a:pPr>
             <a:r>
-              <a:t>•  확장 아이디어 — 난이도 선택, 발음 오디오 추가, 가족/친구 단체 채팅방으로 공유</a:t>
-            </a:r>
-          </a:p>
-        </p:txBody>
-      </p:sp>
-      <p:sp>
-        <p:nvSpPr>
-          <p:cNvPr id="5" name="TextBox 4"/>
+              <a:t>•  더 해보고 싶다면 — 문제 수준 선택하기, 발음 듣기 추가하기, 친구들과 함께 보기</a:t>
+            </a:r>
+          </a:p>
+        </p:txBody>
+      </p:sp>
+      <p:sp>
+        <p:nvSpPr>
+          <p:cNvPr id="5" name="Rectangle 4"/>
+          <p:cNvSpPr/>
+          <p:nvPr/>
+        </p:nvSpPr>
+        <p:spPr>
+          <a:xfrm>
+            <a:off x="640080" y="5989320"/>
+            <a:ext cx="10881360" cy="15240"/>
+          </a:xfrm>
+          <a:prstGeom prst="rect">
+            <a:avLst/>
+          </a:prstGeom>
+          <a:solidFill>
+            <a:srgbClr val="D8DCE6"/>
+          </a:solidFill>
+          <a:ln>
+            <a:noFill/>
+          </a:ln>
+        </p:spPr>
+        <p:style>
+          <a:lnRef idx="1">
+            <a:schemeClr val="accent1"/>
+          </a:lnRef>
+          <a:fillRef idx="3">
+            <a:schemeClr val="accent1"/>
+          </a:fillRef>
+          <a:effectRef idx="2">
+            <a:schemeClr val="accent1"/>
+          </a:effectRef>
+          <a:fontRef idx="minor">
+            <a:schemeClr val="lt1"/>
+          </a:fontRef>
+        </p:style>
+        <p:txBody>
+          <a:bodyPr rtlCol="0" anchor="ctr"/>
+          <a:lstStyle/>
+          <a:p>
+            <a:pPr algn="ctr"/>
+          </a:p>
+        </p:txBody>
+      </p:sp>
+      <p:sp>
+        <p:nvSpPr>
+          <p:cNvPr id="6" name="TextBox 5"/>
+          <p:cNvSpPr txBox="1"/>
+          <p:nvPr/>
+        </p:nvSpPr>
+        <p:spPr>
+          <a:xfrm>
+            <a:off x="640080" y="6080760"/>
+            <a:ext cx="10881360" cy="685800"/>
+          </a:xfrm>
+          <a:prstGeom prst="rect">
+            <a:avLst/>
+          </a:prstGeom>
+          <a:noFill/>
+        </p:spPr>
+        <p:txBody>
+          <a:bodyPr wrap="square">
+            <a:spAutoFit/>
+          </a:bodyPr>
+          <a:lstStyle/>
+          <a:p>
+            <a:r>
+              <a:rPr sz="1100" b="1">
+                <a:solidFill>
+                  <a:srgbClr val="4F8CFF"/>
+                </a:solidFill>
+              </a:rPr>
+              <a:t>용어 설명   </a:t>
+            </a:r>
+            <a:r>
+              <a:rPr sz="1100">
+                <a:solidFill>
+                  <a:srgbClr val="333A4D"/>
+                </a:solidFill>
+              </a:rPr>
+              <a:t/>
+            </a:r>
+            <a:r>
+              <a:rPr sz="1100" b="1">
+                <a:solidFill>
+                  <a:srgbClr val="111C3B"/>
+                </a:solidFill>
+              </a:rPr>
+              <a:t>API 키 </a:t>
+            </a:r>
+            <a:r>
+              <a:rPr sz="1100">
+                <a:solidFill>
+                  <a:srgbClr val="333A4D"/>
+                </a:solidFill>
+              </a:rPr>
+              <a:t>내 계정임을 증명해서 서비스를 사용할 수 있게 해주는 비밀번호 같은 값</a:t>
+            </a:r>
+            <a:r>
+              <a:rPr sz="1100">
+                <a:solidFill>
+                  <a:srgbClr val="333A4D"/>
+                </a:solidFill>
+              </a:rPr>
+              <a:t>     ·     </a:t>
+            </a:r>
+            <a:r>
+              <a:rPr sz="1100" b="1">
+                <a:solidFill>
+                  <a:srgbClr val="111C3B"/>
+                </a:solidFill>
+              </a:rPr>
+              <a:t>GitHub Actions </a:t>
+            </a:r>
+            <a:r>
+              <a:rPr sz="1100">
+                <a:solidFill>
+                  <a:srgbClr val="333A4D"/>
+                </a:solidFill>
+              </a:rPr>
+              <a:t>정해진 시간이나 조건이 되면 컴퓨터가 스스로 작업을 실행해주는 기능</a:t>
+            </a:r>
+          </a:p>
+        </p:txBody>
+      </p:sp>
+      <p:sp>
+        <p:nvSpPr>
+          <p:cNvPr id="7" name="TextBox 6"/>
           <p:cNvSpPr txBox="1"/>
           <p:nvPr/>
         </p:nvSpPr>
@@ -5141,7 +6077,7 @@
         <p:spPr>
           <a:xfrm>
             <a:off x="640080" y="1417320"/>
-            <a:ext cx="10881360" cy="4754880"/>
+            <a:ext cx="10881360" cy="5394960"/>
           </a:xfrm>
           <a:prstGeom prst="rect">
             <a:avLst/>
@@ -5165,7 +6101,7 @@
               </a:defRPr>
             </a:pPr>
             <a:r>
-              <a:t>•  Visual Studio는 AI 네이티브 IDE로 진화 중이며, Claude Code와 결합하면 강력한 개발 파트너가 됨</a:t>
+              <a:t>•  Visual Studio는 코드를 쉽게 짤 수 있게 도와주는 프로그램이고, Claude Code는 AI로 코드를 대신 써주는 도우미예요</a:t>
             </a:r>
           </a:p>
           <a:p>
@@ -5180,7 +6116,7 @@
               </a:defRPr>
             </a:pPr>
             <a:r>
-              <a:t>•  JSON과 GitHub의 무료 도구(Pages, Actions)를 조합하면 별도 서버 없이도 자동화 서비스를 만들 수 있음</a:t>
+              <a:t>•  JSON과 GitHub의 무료 도구들을 함께 쓰면, 서버 없이도 나만의 자동화 프로그램(에이전트)을 만들 수 있어요</a:t>
             </a:r>
           </a:p>
           <a:p>
@@ -5195,7 +6131,7 @@
               </a:defRPr>
             </a:pPr>
             <a:r>
-              <a:t>•  오늘 실습한 '매일 영어회화 웹페이지 + 카카오톡 알림'처럼, 나만의 아이디어를 Agent로 직접 만들어보세요</a:t>
+              <a:t>•  오늘처럼 '매일 영어회화 웹페이지'같은 재미있는 아이디어를 직접 만들어 보세요!</a:t>
             </a:r>
           </a:p>
         </p:txBody>

</xml_diff>

<commit_message>
Add flow diagrams, bigger slide text, and third example deck
- generator/build_deck.py: content slides can carry a "diagram" list
  (step labels) rendered as a box-and-arrow flow diagram in both the
  PPTX and the Reveal.js deck, for process/sequence content that reads
  better as a picture than a bullet list.
- Increased font sizes across both outputs (titles, bullets, terms,
  code, diagram boxes) for readability, with the PPTX body textbox now
  set to shrink-to-fit as a safety net and the HTML density thresholds
  tightened slightly to compensate.
- generator/gui.py: the request note sent to Claude Code now explains
  the diagram field so future decks use it where it helps (process
  slides, comparisons), in both the new-deck and revision flows.
- Add third example deck (docs/03-vs-code-agent/): "VS Code를 이용한
  Agent 만들기 개념 정리", built via the concept-only flow, including
  one flow-diagram slide. Rebuilt with the new sizing.

Co-Authored-By: Claude Sonnet 5 <noreply@anthropic.com>
</commit_message>
<xml_diff>
--- a/docs/01-visual-studio-agent/slides.pptx
+++ b/docs/01-visual-studio-agent/slides.pptx
@@ -3127,7 +3127,7 @@
           <a:lstStyle/>
           <a:p>
             <a:pPr>
-              <a:defRPr sz="4000" b="1">
+              <a:defRPr sz="4400" b="1">
                 <a:solidFill>
                   <a:srgbClr val="FFFFFF"/>
                 </a:solidFill>
@@ -3162,7 +3162,7 @@
           <a:lstStyle/>
           <a:p>
             <a:pPr>
-              <a:defRPr sz="2200">
+              <a:defRPr sz="2400">
                 <a:solidFill>
                   <a:srgbClr val="4F8CFF"/>
                 </a:solidFill>
@@ -3197,7 +3197,7 @@
           <a:lstStyle/>
           <a:p>
             <a:pPr>
-              <a:defRPr sz="1600">
+              <a:defRPr sz="1800">
                 <a:solidFill>
                   <a:srgbClr val="CCD6F6"/>
                 </a:solidFill>
@@ -3344,7 +3344,7 @@
           <a:lstStyle/>
           <a:p>
             <a:pPr>
-              <a:defRPr sz="3000" b="1">
+              <a:defRPr sz="3200" b="1">
                 <a:solidFill>
                   <a:srgbClr val="111C3B"/>
                 </a:solidFill>
@@ -3374,7 +3374,7 @@
         </p:spPr>
         <p:txBody>
           <a:bodyPr wrap="square">
-            <a:spAutoFit/>
+            <a:normAutofit/>
           </a:bodyPr>
           <a:lstStyle/>
           <a:p>
@@ -3382,7 +3382,7 @@
               <a:spcAft>
                 <a:spcPts val="1200"/>
               </a:spcAft>
-              <a:defRPr sz="1700">
+              <a:defRPr sz="1900">
                 <a:solidFill>
                   <a:srgbClr val="333A4D"/>
                 </a:solidFill>
@@ -3397,7 +3397,7 @@
               <a:spcAft>
                 <a:spcPts val="1200"/>
               </a:spcAft>
-              <a:defRPr sz="1700">
+              <a:defRPr sz="1900">
                 <a:solidFill>
                   <a:srgbClr val="333A4D"/>
                 </a:solidFill>
@@ -3412,7 +3412,7 @@
               <a:spcAft>
                 <a:spcPts val="1200"/>
               </a:spcAft>
-              <a:defRPr sz="1700">
+              <a:defRPr sz="1900">
                 <a:solidFill>
                   <a:srgbClr val="333A4D"/>
                 </a:solidFill>
@@ -3427,7 +3427,7 @@
               <a:spcAft>
                 <a:spcPts val="1200"/>
               </a:spcAft>
-              <a:defRPr sz="1700">
+              <a:defRPr sz="1900">
                 <a:solidFill>
                   <a:srgbClr val="333A4D"/>
                 </a:solidFill>
@@ -3442,7 +3442,7 @@
               <a:spcAft>
                 <a:spcPts val="1200"/>
               </a:spcAft>
-              <a:defRPr sz="1700">
+              <a:defRPr sz="1900">
                 <a:solidFill>
                   <a:srgbClr val="333A4D"/>
                 </a:solidFill>
@@ -3520,7 +3520,7 @@
           <a:lstStyle/>
           <a:p>
             <a:r>
-              <a:rPr sz="1100" b="1">
+              <a:rPr sz="1200" b="1">
                 <a:solidFill>
                   <a:srgbClr val="4F8CFF"/>
                 </a:solidFill>
@@ -3528,7 +3528,7 @@
               <a:t>용어 설명   </a:t>
             </a:r>
             <a:r>
-              <a:rPr sz="1100">
+              <a:rPr sz="1200">
                 <a:solidFill>
                   <a:srgbClr val="333A4D"/>
                 </a:solidFill>
@@ -3536,7 +3536,7 @@
               <a:t/>
             </a:r>
             <a:r>
-              <a:rPr sz="1100" b="1">
+              <a:rPr sz="1200" b="1">
                 <a:solidFill>
                   <a:srgbClr val="111C3B"/>
                 </a:solidFill>
@@ -3544,7 +3544,7 @@
               <a:t>코드(Code) </a:t>
             </a:r>
             <a:r>
-              <a:rPr sz="1100">
+              <a:rPr sz="1200">
                 <a:solidFill>
                   <a:srgbClr val="333A4D"/>
                 </a:solidFill>
@@ -3552,7 +3552,7 @@
               <a:t>컴퓨터에게 무엇을 하라고 알려주는 명령어 모음</a:t>
             </a:r>
             <a:r>
-              <a:rPr sz="1100">
+              <a:rPr sz="1200">
                 <a:solidFill>
                   <a:srgbClr val="333A4D"/>
                 </a:solidFill>
@@ -3560,7 +3560,7 @@
               <a:t>     ·     </a:t>
             </a:r>
             <a:r>
-              <a:rPr sz="1100" b="1">
+              <a:rPr sz="1200" b="1">
                 <a:solidFill>
                   <a:srgbClr val="111C3B"/>
                 </a:solidFill>
@@ -3568,7 +3568,7 @@
               <a:t>IDE </a:t>
             </a:r>
             <a:r>
-              <a:rPr sz="1100">
+              <a:rPr sz="1200">
                 <a:solidFill>
                   <a:srgbClr val="333A4D"/>
                 </a:solidFill>
@@ -3705,7 +3705,7 @@
           <a:lstStyle/>
           <a:p>
             <a:pPr>
-              <a:defRPr sz="3000" b="1">
+              <a:defRPr sz="3200" b="1">
                 <a:solidFill>
                   <a:srgbClr val="111C3B"/>
                 </a:solidFill>
@@ -3735,7 +3735,7 @@
         </p:spPr>
         <p:txBody>
           <a:bodyPr wrap="square">
-            <a:spAutoFit/>
+            <a:normAutofit/>
           </a:bodyPr>
           <a:lstStyle/>
           <a:p>
@@ -3743,7 +3743,7 @@
               <a:spcAft>
                 <a:spcPts val="1200"/>
               </a:spcAft>
-              <a:defRPr sz="1700">
+              <a:defRPr sz="1900">
                 <a:solidFill>
                   <a:srgbClr val="333A4D"/>
                 </a:solidFill>
@@ -3758,7 +3758,7 @@
               <a:spcAft>
                 <a:spcPts val="1200"/>
               </a:spcAft>
-              <a:defRPr sz="1700">
+              <a:defRPr sz="1900">
                 <a:solidFill>
                   <a:srgbClr val="333A4D"/>
                 </a:solidFill>
@@ -3773,7 +3773,7 @@
               <a:spcAft>
                 <a:spcPts val="1200"/>
               </a:spcAft>
-              <a:defRPr sz="1700">
+              <a:defRPr sz="1900">
                 <a:solidFill>
                   <a:srgbClr val="333A4D"/>
                 </a:solidFill>
@@ -3788,7 +3788,7 @@
               <a:spcAft>
                 <a:spcPts val="1200"/>
               </a:spcAft>
-              <a:defRPr sz="1700">
+              <a:defRPr sz="1900">
                 <a:solidFill>
                   <a:srgbClr val="333A4D"/>
                 </a:solidFill>
@@ -3803,7 +3803,7 @@
               <a:spcAft>
                 <a:spcPts val="1200"/>
               </a:spcAft>
-              <a:defRPr sz="1700">
+              <a:defRPr sz="1900">
                 <a:solidFill>
                   <a:srgbClr val="333A4D"/>
                 </a:solidFill>
@@ -3818,7 +3818,7 @@
               <a:spcAft>
                 <a:spcPts val="1200"/>
               </a:spcAft>
-              <a:defRPr sz="1700">
+              <a:defRPr sz="1900">
                 <a:solidFill>
                   <a:srgbClr val="333A4D"/>
                 </a:solidFill>
@@ -3833,7 +3833,7 @@
               <a:spcAft>
                 <a:spcPts val="1200"/>
               </a:spcAft>
-              <a:defRPr sz="1700">
+              <a:defRPr sz="1900">
                 <a:solidFill>
                   <a:srgbClr val="333A4D"/>
                 </a:solidFill>
@@ -3911,7 +3911,7 @@
           <a:lstStyle/>
           <a:p>
             <a:r>
-              <a:rPr sz="1100" b="1">
+              <a:rPr sz="1200" b="1">
                 <a:solidFill>
                   <a:srgbClr val="4F8CFF"/>
                 </a:solidFill>
@@ -3919,7 +3919,7 @@
               <a:t>용어 설명   </a:t>
             </a:r>
             <a:r>
-              <a:rPr sz="1100">
+              <a:rPr sz="1200">
                 <a:solidFill>
                   <a:srgbClr val="333A4D"/>
                 </a:solidFill>
@@ -3927,7 +3927,7 @@
               <a:t/>
             </a:r>
             <a:r>
-              <a:rPr sz="1100" b="1">
+              <a:rPr sz="1200" b="1">
                 <a:solidFill>
                   <a:srgbClr val="111C3B"/>
                 </a:solidFill>
@@ -3935,7 +3935,7 @@
               <a:t>버그(Bug) </a:t>
             </a:r>
             <a:r>
-              <a:rPr sz="1100">
+              <a:rPr sz="1200">
                 <a:solidFill>
                   <a:srgbClr val="333A4D"/>
                 </a:solidFill>
@@ -3943,7 +3943,7 @@
               <a:t>프로그램에서 잘못 작동하는 부분</a:t>
             </a:r>
             <a:r>
-              <a:rPr sz="1100">
+              <a:rPr sz="1200">
                 <a:solidFill>
                   <a:srgbClr val="333A4D"/>
                 </a:solidFill>
@@ -3951,7 +3951,7 @@
               <a:t>     ·     </a:t>
             </a:r>
             <a:r>
-              <a:rPr sz="1100" b="1">
+              <a:rPr sz="1200" b="1">
                 <a:solidFill>
                   <a:srgbClr val="111C3B"/>
                 </a:solidFill>
@@ -3959,7 +3959,7 @@
               <a:t>디버깅 </a:t>
             </a:r>
             <a:r>
-              <a:rPr sz="1100">
+              <a:rPr sz="1200">
                 <a:solidFill>
                   <a:srgbClr val="333A4D"/>
                 </a:solidFill>
@@ -3967,7 +3967,7 @@
               <a:t>버그를 찾아서 고치는 작업</a:t>
             </a:r>
             <a:r>
-              <a:rPr sz="1100">
+              <a:rPr sz="1200">
                 <a:solidFill>
                   <a:srgbClr val="333A4D"/>
                 </a:solidFill>
@@ -3975,7 +3975,7 @@
               <a:t>     ·     </a:t>
             </a:r>
             <a:r>
-              <a:rPr sz="1100" b="1">
+              <a:rPr sz="1200" b="1">
                 <a:solidFill>
                   <a:srgbClr val="111C3B"/>
                 </a:solidFill>
@@ -3983,7 +3983,7 @@
               <a:t>Git </a:t>
             </a:r>
             <a:r>
-              <a:rPr sz="1100">
+              <a:rPr sz="1200">
                 <a:solidFill>
                   <a:srgbClr val="333A4D"/>
                 </a:solidFill>
@@ -4120,7 +4120,7 @@
           <a:lstStyle/>
           <a:p>
             <a:pPr>
-              <a:defRPr sz="3000" b="1">
+              <a:defRPr sz="3200" b="1">
                 <a:solidFill>
                   <a:srgbClr val="111C3B"/>
                 </a:solidFill>
@@ -4150,7 +4150,7 @@
         </p:spPr>
         <p:txBody>
           <a:bodyPr wrap="square">
-            <a:spAutoFit/>
+            <a:normAutofit/>
           </a:bodyPr>
           <a:lstStyle/>
           <a:p>
@@ -4158,7 +4158,7 @@
               <a:spcAft>
                 <a:spcPts val="1200"/>
               </a:spcAft>
-              <a:defRPr sz="1700">
+              <a:defRPr sz="1900">
                 <a:solidFill>
                   <a:srgbClr val="333A4D"/>
                 </a:solidFill>
@@ -4173,7 +4173,7 @@
               <a:spcAft>
                 <a:spcPts val="1200"/>
               </a:spcAft>
-              <a:defRPr sz="1700">
+              <a:defRPr sz="1900">
                 <a:solidFill>
                   <a:srgbClr val="333A4D"/>
                 </a:solidFill>
@@ -4188,7 +4188,7 @@
               <a:spcAft>
                 <a:spcPts val="1200"/>
               </a:spcAft>
-              <a:defRPr sz="1700">
+              <a:defRPr sz="1900">
                 <a:solidFill>
                   <a:srgbClr val="333A4D"/>
                 </a:solidFill>
@@ -4203,7 +4203,7 @@
               <a:spcAft>
                 <a:spcPts val="1200"/>
               </a:spcAft>
-              <a:defRPr sz="1700">
+              <a:defRPr sz="1900">
                 <a:solidFill>
                   <a:srgbClr val="333A4D"/>
                 </a:solidFill>
@@ -4218,7 +4218,7 @@
               <a:spcAft>
                 <a:spcPts val="1200"/>
               </a:spcAft>
-              <a:defRPr sz="1700">
+              <a:defRPr sz="1900">
                 <a:solidFill>
                   <a:srgbClr val="333A4D"/>
                 </a:solidFill>
@@ -4255,7 +4255,7 @@
           <a:lstStyle/>
           <a:p>
             <a:pPr>
-              <a:defRPr sz="1300">
+              <a:defRPr sz="1400">
                 <a:solidFill>
                   <a:srgbClr val="9CD8FF"/>
                 </a:solidFill>
@@ -4268,7 +4268,7 @@
           </a:p>
           <a:p>
             <a:pPr>
-              <a:defRPr sz="1300">
+              <a:defRPr sz="1400">
                 <a:solidFill>
                   <a:srgbClr val="9CD8FF"/>
                 </a:solidFill>
@@ -4281,7 +4281,7 @@
           </a:p>
           <a:p>
             <a:pPr>
-              <a:defRPr sz="1300">
+              <a:defRPr sz="1400">
                 <a:solidFill>
                   <a:srgbClr val="9CD8FF"/>
                 </a:solidFill>
@@ -4294,7 +4294,7 @@
           </a:p>
           <a:p>
             <a:pPr>
-              <a:defRPr sz="1300">
+              <a:defRPr sz="1400">
                 <a:solidFill>
                   <a:srgbClr val="9CD8FF"/>
                 </a:solidFill>
@@ -4373,7 +4373,7 @@
           <a:lstStyle/>
           <a:p>
             <a:r>
-              <a:rPr sz="1100" b="1">
+              <a:rPr sz="1200" b="1">
                 <a:solidFill>
                   <a:srgbClr val="4F8CFF"/>
                 </a:solidFill>
@@ -4381,7 +4381,7 @@
               <a:t>용어 설명   </a:t>
             </a:r>
             <a:r>
-              <a:rPr sz="1100">
+              <a:rPr sz="1200">
                 <a:solidFill>
                   <a:srgbClr val="333A4D"/>
                 </a:solidFill>
@@ -4389,7 +4389,7 @@
               <a:t/>
             </a:r>
             <a:r>
-              <a:rPr sz="1100" b="1">
+              <a:rPr sz="1200" b="1">
                 <a:solidFill>
                   <a:srgbClr val="111C3B"/>
                 </a:solidFill>
@@ -4397,7 +4397,7 @@
               <a:t>이름표-내용(Key-Value) </a:t>
             </a:r>
             <a:r>
-              <a:rPr sz="1100">
+              <a:rPr sz="1200">
                 <a:solidFill>
                   <a:srgbClr val="333A4D"/>
                 </a:solidFill>
@@ -4405,7 +4405,7 @@
               <a:t>'이름표: 내용'처럼 한 쌍으로 짝지어 정보를 적는 방식</a:t>
             </a:r>
             <a:r>
-              <a:rPr sz="1100">
+              <a:rPr sz="1200">
                 <a:solidFill>
                   <a:srgbClr val="333A4D"/>
                 </a:solidFill>
@@ -4413,7 +4413,7 @@
               <a:t>     ·     </a:t>
             </a:r>
             <a:r>
-              <a:rPr sz="1100" b="1">
+              <a:rPr sz="1200" b="1">
                 <a:solidFill>
                   <a:srgbClr val="111C3B"/>
                 </a:solidFill>
@@ -4421,7 +4421,7 @@
               <a:t>설정 파일 </a:t>
             </a:r>
             <a:r>
-              <a:rPr sz="1100">
+              <a:rPr sz="1200">
                 <a:solidFill>
                   <a:srgbClr val="333A4D"/>
                 </a:solidFill>
@@ -4558,7 +4558,7 @@
           <a:lstStyle/>
           <a:p>
             <a:pPr>
-              <a:defRPr sz="3000" b="1">
+              <a:defRPr sz="3200" b="1">
                 <a:solidFill>
                   <a:srgbClr val="111C3B"/>
                 </a:solidFill>
@@ -4588,7 +4588,7 @@
         </p:spPr>
         <p:txBody>
           <a:bodyPr wrap="square">
-            <a:spAutoFit/>
+            <a:normAutofit/>
           </a:bodyPr>
           <a:lstStyle/>
           <a:p>
@@ -4596,7 +4596,7 @@
               <a:spcAft>
                 <a:spcPts val="1200"/>
               </a:spcAft>
-              <a:defRPr sz="1700">
+              <a:defRPr sz="1900">
                 <a:solidFill>
                   <a:srgbClr val="333A4D"/>
                 </a:solidFill>
@@ -4611,7 +4611,7 @@
               <a:spcAft>
                 <a:spcPts val="1200"/>
               </a:spcAft>
-              <a:defRPr sz="1700">
+              <a:defRPr sz="1900">
                 <a:solidFill>
                   <a:srgbClr val="333A4D"/>
                 </a:solidFill>
@@ -4626,7 +4626,7 @@
               <a:spcAft>
                 <a:spcPts val="1200"/>
               </a:spcAft>
-              <a:defRPr sz="1700">
+              <a:defRPr sz="1900">
                 <a:solidFill>
                   <a:srgbClr val="333A4D"/>
                 </a:solidFill>
@@ -4641,7 +4641,7 @@
               <a:spcAft>
                 <a:spcPts val="1200"/>
               </a:spcAft>
-              <a:defRPr sz="1700">
+              <a:defRPr sz="1900">
                 <a:solidFill>
                   <a:srgbClr val="333A4D"/>
                 </a:solidFill>
@@ -4656,7 +4656,7 @@
               <a:spcAft>
                 <a:spcPts val="1200"/>
               </a:spcAft>
-              <a:defRPr sz="1700">
+              <a:defRPr sz="1900">
                 <a:solidFill>
                   <a:srgbClr val="333A4D"/>
                 </a:solidFill>
@@ -4734,7 +4734,7 @@
           <a:lstStyle/>
           <a:p>
             <a:r>
-              <a:rPr sz="1100" b="1">
+              <a:rPr sz="1200" b="1">
                 <a:solidFill>
                   <a:srgbClr val="4F8CFF"/>
                 </a:solidFill>
@@ -4742,7 +4742,7 @@
               <a:t>용어 설명   </a:t>
             </a:r>
             <a:r>
-              <a:rPr sz="1100">
+              <a:rPr sz="1200">
                 <a:solidFill>
                   <a:srgbClr val="333A4D"/>
                 </a:solidFill>
@@ -4750,7 +4750,7 @@
               <a:t/>
             </a:r>
             <a:r>
-              <a:rPr sz="1100" b="1">
+              <a:rPr sz="1200" b="1">
                 <a:solidFill>
                   <a:srgbClr val="111C3B"/>
                 </a:solidFill>
@@ -4758,7 +4758,7 @@
               <a:t>AI 에이전트 </a:t>
             </a:r>
             <a:r>
-              <a:rPr sz="1100">
+              <a:rPr sz="1200">
                 <a:solidFill>
                   <a:srgbClr val="333A4D"/>
                 </a:solidFill>
@@ -4766,7 +4766,7 @@
               <a:t>스스로 판단해서 여러 작업을 척척 해내는 AI 프로그램</a:t>
             </a:r>
             <a:r>
-              <a:rPr sz="1100">
+              <a:rPr sz="1200">
                 <a:solidFill>
                   <a:srgbClr val="333A4D"/>
                 </a:solidFill>
@@ -4774,7 +4774,7 @@
               <a:t>     ·     </a:t>
             </a:r>
             <a:r>
-              <a:rPr sz="1100" b="1">
+              <a:rPr sz="1200" b="1">
                 <a:solidFill>
                   <a:srgbClr val="111C3B"/>
                 </a:solidFill>
@@ -4782,7 +4782,7 @@
               <a:t>Plan Mode </a:t>
             </a:r>
             <a:r>
-              <a:rPr sz="1100">
+              <a:rPr sz="1200">
                 <a:solidFill>
                   <a:srgbClr val="333A4D"/>
                 </a:solidFill>
@@ -4919,7 +4919,7 @@
           <a:lstStyle/>
           <a:p>
             <a:pPr>
-              <a:defRPr sz="3000" b="1">
+              <a:defRPr sz="3200" b="1">
                 <a:solidFill>
                   <a:srgbClr val="111C3B"/>
                 </a:solidFill>
@@ -4949,7 +4949,7 @@
         </p:spPr>
         <p:txBody>
           <a:bodyPr wrap="square">
-            <a:spAutoFit/>
+            <a:normAutofit/>
           </a:bodyPr>
           <a:lstStyle/>
           <a:p>
@@ -4957,7 +4957,7 @@
               <a:spcAft>
                 <a:spcPts val="1200"/>
               </a:spcAft>
-              <a:defRPr sz="1700">
+              <a:defRPr sz="1900">
                 <a:solidFill>
                   <a:srgbClr val="333A4D"/>
                 </a:solidFill>
@@ -4972,7 +4972,7 @@
               <a:spcAft>
                 <a:spcPts val="1200"/>
               </a:spcAft>
-              <a:defRPr sz="1700">
+              <a:defRPr sz="1900">
                 <a:solidFill>
                   <a:srgbClr val="333A4D"/>
                 </a:solidFill>
@@ -4987,7 +4987,7 @@
               <a:spcAft>
                 <a:spcPts val="1200"/>
               </a:spcAft>
-              <a:defRPr sz="1700">
+              <a:defRPr sz="1900">
                 <a:solidFill>
                   <a:srgbClr val="333A4D"/>
                 </a:solidFill>
@@ -5002,7 +5002,7 @@
               <a:spcAft>
                 <a:spcPts val="1200"/>
               </a:spcAft>
-              <a:defRPr sz="1700">
+              <a:defRPr sz="1900">
                 <a:solidFill>
                   <a:srgbClr val="333A4D"/>
                 </a:solidFill>
@@ -5017,7 +5017,7 @@
               <a:spcAft>
                 <a:spcPts val="1200"/>
               </a:spcAft>
-              <a:defRPr sz="1700">
+              <a:defRPr sz="1900">
                 <a:solidFill>
                   <a:srgbClr val="333A4D"/>
                 </a:solidFill>
@@ -5032,7 +5032,7 @@
               <a:spcAft>
                 <a:spcPts val="1200"/>
               </a:spcAft>
-              <a:defRPr sz="1700">
+              <a:defRPr sz="1900">
                 <a:solidFill>
                   <a:srgbClr val="333A4D"/>
                 </a:solidFill>
@@ -5110,7 +5110,7 @@
           <a:lstStyle/>
           <a:p>
             <a:r>
-              <a:rPr sz="1100" b="1">
+              <a:rPr sz="1200" b="1">
                 <a:solidFill>
                   <a:srgbClr val="4F8CFF"/>
                 </a:solidFill>
@@ -5118,7 +5118,7 @@
               <a:t>용어 설명   </a:t>
             </a:r>
             <a:r>
-              <a:rPr sz="1100">
+              <a:rPr sz="1200">
                 <a:solidFill>
                   <a:srgbClr val="333A4D"/>
                 </a:solidFill>
@@ -5126,7 +5126,7 @@
               <a:t/>
             </a:r>
             <a:r>
-              <a:rPr sz="1100" b="1">
+              <a:rPr sz="1200" b="1">
                 <a:solidFill>
                   <a:srgbClr val="111C3B"/>
                 </a:solidFill>
@@ -5134,7 +5134,7 @@
               <a:t>터미널 </a:t>
             </a:r>
             <a:r>
-              <a:rPr sz="1100">
+              <a:rPr sz="1200">
                 <a:solidFill>
                   <a:srgbClr val="333A4D"/>
                 </a:solidFill>
@@ -5142,7 +5142,7 @@
               <a:t>글자로 명령어를 입력해서 컴퓨터에게 일을 시키는 화면</a:t>
             </a:r>
             <a:r>
-              <a:rPr sz="1100">
+              <a:rPr sz="1200">
                 <a:solidFill>
                   <a:srgbClr val="333A4D"/>
                 </a:solidFill>
@@ -5150,7 +5150,7 @@
               <a:t>     ·     </a:t>
             </a:r>
             <a:r>
-              <a:rPr sz="1100" b="1">
+              <a:rPr sz="1200" b="1">
                 <a:solidFill>
                   <a:srgbClr val="111C3B"/>
                 </a:solidFill>
@@ -5158,7 +5158,7 @@
               <a:t>확장 프로그램 </a:t>
             </a:r>
             <a:r>
-              <a:rPr sz="1100">
+              <a:rPr sz="1200">
                 <a:solidFill>
                   <a:srgbClr val="333A4D"/>
                 </a:solidFill>
@@ -5295,7 +5295,7 @@
           <a:lstStyle/>
           <a:p>
             <a:pPr>
-              <a:defRPr sz="3000" b="1">
+              <a:defRPr sz="3200" b="1">
                 <a:solidFill>
                   <a:srgbClr val="111C3B"/>
                 </a:solidFill>
@@ -5325,7 +5325,7 @@
         </p:spPr>
         <p:txBody>
           <a:bodyPr wrap="square">
-            <a:spAutoFit/>
+            <a:normAutofit/>
           </a:bodyPr>
           <a:lstStyle/>
           <a:p>
@@ -5333,7 +5333,7 @@
               <a:spcAft>
                 <a:spcPts val="1200"/>
               </a:spcAft>
-              <a:defRPr sz="1700">
+              <a:defRPr sz="1900">
                 <a:solidFill>
                   <a:srgbClr val="333A4D"/>
                 </a:solidFill>
@@ -5348,7 +5348,7 @@
               <a:spcAft>
                 <a:spcPts val="1200"/>
               </a:spcAft>
-              <a:defRPr sz="1700">
+              <a:defRPr sz="1900">
                 <a:solidFill>
                   <a:srgbClr val="333A4D"/>
                 </a:solidFill>
@@ -5363,7 +5363,7 @@
               <a:spcAft>
                 <a:spcPts val="1200"/>
               </a:spcAft>
-              <a:defRPr sz="1700">
+              <a:defRPr sz="1900">
                 <a:solidFill>
                   <a:srgbClr val="333A4D"/>
                 </a:solidFill>
@@ -5378,7 +5378,7 @@
               <a:spcAft>
                 <a:spcPts val="1200"/>
               </a:spcAft>
-              <a:defRPr sz="1700">
+              <a:defRPr sz="1900">
                 <a:solidFill>
                   <a:srgbClr val="333A4D"/>
                 </a:solidFill>
@@ -5393,7 +5393,7 @@
               <a:spcAft>
                 <a:spcPts val="1200"/>
               </a:spcAft>
-              <a:defRPr sz="1700">
+              <a:defRPr sz="1900">
                 <a:solidFill>
                   <a:srgbClr val="333A4D"/>
                 </a:solidFill>
@@ -5471,7 +5471,7 @@
           <a:lstStyle/>
           <a:p>
             <a:r>
-              <a:rPr sz="1100" b="1">
+              <a:rPr sz="1200" b="1">
                 <a:solidFill>
                   <a:srgbClr val="4F8CFF"/>
                 </a:solidFill>
@@ -5479,7 +5479,7 @@
               <a:t>용어 설명   </a:t>
             </a:r>
             <a:r>
-              <a:rPr sz="1100">
+              <a:rPr sz="1200">
                 <a:solidFill>
                   <a:srgbClr val="333A4D"/>
                 </a:solidFill>
@@ -5487,7 +5487,7 @@
               <a:t/>
             </a:r>
             <a:r>
-              <a:rPr sz="1100" b="1">
+              <a:rPr sz="1200" b="1">
                 <a:solidFill>
                   <a:srgbClr val="111C3B"/>
                 </a:solidFill>
@@ -5495,7 +5495,7 @@
               <a:t>저장소(Repository) </a:t>
             </a:r>
             <a:r>
-              <a:rPr sz="1100">
+              <a:rPr sz="1200">
                 <a:solidFill>
                   <a:srgbClr val="333A4D"/>
                 </a:solidFill>
@@ -5503,7 +5503,7 @@
               <a:t>코드와 파일들을 모아두는 폴더 같은 공간</a:t>
             </a:r>
             <a:r>
-              <a:rPr sz="1100">
+              <a:rPr sz="1200">
                 <a:solidFill>
                   <a:srgbClr val="333A4D"/>
                 </a:solidFill>
@@ -5511,7 +5511,7 @@
               <a:t>     ·     </a:t>
             </a:r>
             <a:r>
-              <a:rPr sz="1100" b="1">
+              <a:rPr sz="1200" b="1">
                 <a:solidFill>
                   <a:srgbClr val="111C3B"/>
                 </a:solidFill>
@@ -5519,7 +5519,7 @@
               <a:t>API </a:t>
             </a:r>
             <a:r>
-              <a:rPr sz="1100">
+              <a:rPr sz="1200">
                 <a:solidFill>
                   <a:srgbClr val="333A4D"/>
                 </a:solidFill>
@@ -5527,7 +5527,7 @@
               <a:t>서로 다른 프로그램이 정보를 주고받을 수 있게 해주는 규칙과 통로</a:t>
             </a:r>
             <a:r>
-              <a:rPr sz="1100">
+              <a:rPr sz="1200">
                 <a:solidFill>
                   <a:srgbClr val="333A4D"/>
                 </a:solidFill>
@@ -5535,7 +5535,7 @@
               <a:t>     ·     </a:t>
             </a:r>
             <a:r>
-              <a:rPr sz="1100" b="1">
+              <a:rPr sz="1200" b="1">
                 <a:solidFill>
                   <a:srgbClr val="111C3B"/>
                 </a:solidFill>
@@ -5543,7 +5543,7 @@
               <a:t>자동화 </a:t>
             </a:r>
             <a:r>
-              <a:rPr sz="1100">
+              <a:rPr sz="1200">
                 <a:solidFill>
                   <a:srgbClr val="333A4D"/>
                 </a:solidFill>
@@ -5680,7 +5680,7 @@
           <a:lstStyle/>
           <a:p>
             <a:pPr>
-              <a:defRPr sz="3000" b="1">
+              <a:defRPr sz="3200" b="1">
                 <a:solidFill>
                   <a:srgbClr val="111C3B"/>
                 </a:solidFill>
@@ -5710,7 +5710,7 @@
         </p:spPr>
         <p:txBody>
           <a:bodyPr wrap="square">
-            <a:spAutoFit/>
+            <a:normAutofit/>
           </a:bodyPr>
           <a:lstStyle/>
           <a:p>
@@ -5718,7 +5718,7 @@
               <a:spcAft>
                 <a:spcPts val="1200"/>
               </a:spcAft>
-              <a:defRPr sz="1700">
+              <a:defRPr sz="1900">
                 <a:solidFill>
                   <a:srgbClr val="333A4D"/>
                 </a:solidFill>
@@ -5733,7 +5733,7 @@
               <a:spcAft>
                 <a:spcPts val="1200"/>
               </a:spcAft>
-              <a:defRPr sz="1700">
+              <a:defRPr sz="1900">
                 <a:solidFill>
                   <a:srgbClr val="333A4D"/>
                 </a:solidFill>
@@ -5748,7 +5748,7 @@
               <a:spcAft>
                 <a:spcPts val="1200"/>
               </a:spcAft>
-              <a:defRPr sz="1700">
+              <a:defRPr sz="1900">
                 <a:solidFill>
                   <a:srgbClr val="333A4D"/>
                 </a:solidFill>
@@ -5763,7 +5763,7 @@
               <a:spcAft>
                 <a:spcPts val="1200"/>
               </a:spcAft>
-              <a:defRPr sz="1700">
+              <a:defRPr sz="1900">
                 <a:solidFill>
                   <a:srgbClr val="333A4D"/>
                 </a:solidFill>
@@ -5778,7 +5778,7 @@
               <a:spcAft>
                 <a:spcPts val="1200"/>
               </a:spcAft>
-              <a:defRPr sz="1700">
+              <a:defRPr sz="1900">
                 <a:solidFill>
                   <a:srgbClr val="333A4D"/>
                 </a:solidFill>
@@ -5793,7 +5793,7 @@
               <a:spcAft>
                 <a:spcPts val="1200"/>
               </a:spcAft>
-              <a:defRPr sz="1700">
+              <a:defRPr sz="1900">
                 <a:solidFill>
                   <a:srgbClr val="333A4D"/>
                 </a:solidFill>
@@ -5871,7 +5871,7 @@
           <a:lstStyle/>
           <a:p>
             <a:r>
-              <a:rPr sz="1100" b="1">
+              <a:rPr sz="1200" b="1">
                 <a:solidFill>
                   <a:srgbClr val="4F8CFF"/>
                 </a:solidFill>
@@ -5879,7 +5879,7 @@
               <a:t>용어 설명   </a:t>
             </a:r>
             <a:r>
-              <a:rPr sz="1100">
+              <a:rPr sz="1200">
                 <a:solidFill>
                   <a:srgbClr val="333A4D"/>
                 </a:solidFill>
@@ -5887,7 +5887,7 @@
               <a:t/>
             </a:r>
             <a:r>
-              <a:rPr sz="1100" b="1">
+              <a:rPr sz="1200" b="1">
                 <a:solidFill>
                   <a:srgbClr val="111C3B"/>
                 </a:solidFill>
@@ -5895,7 +5895,7 @@
               <a:t>API 키 </a:t>
             </a:r>
             <a:r>
-              <a:rPr sz="1100">
+              <a:rPr sz="1200">
                 <a:solidFill>
                   <a:srgbClr val="333A4D"/>
                 </a:solidFill>
@@ -5903,7 +5903,7 @@
               <a:t>내 계정임을 증명해서 서비스를 사용할 수 있게 해주는 비밀번호 같은 값</a:t>
             </a:r>
             <a:r>
-              <a:rPr sz="1100">
+              <a:rPr sz="1200">
                 <a:solidFill>
                   <a:srgbClr val="333A4D"/>
                 </a:solidFill>
@@ -5911,7 +5911,7 @@
               <a:t>     ·     </a:t>
             </a:r>
             <a:r>
-              <a:rPr sz="1100" b="1">
+              <a:rPr sz="1200" b="1">
                 <a:solidFill>
                   <a:srgbClr val="111C3B"/>
                 </a:solidFill>
@@ -5919,7 +5919,7 @@
               <a:t>GitHub Actions </a:t>
             </a:r>
             <a:r>
-              <a:rPr sz="1100">
+              <a:rPr sz="1200">
                 <a:solidFill>
                   <a:srgbClr val="333A4D"/>
                 </a:solidFill>
@@ -6056,7 +6056,7 @@
           <a:lstStyle/>
           <a:p>
             <a:pPr>
-              <a:defRPr sz="3000" b="1">
+              <a:defRPr sz="3200" b="1">
                 <a:solidFill>
                   <a:srgbClr val="111C3B"/>
                 </a:solidFill>
@@ -6086,7 +6086,7 @@
         </p:spPr>
         <p:txBody>
           <a:bodyPr wrap="square">
-            <a:spAutoFit/>
+            <a:normAutofit/>
           </a:bodyPr>
           <a:lstStyle/>
           <a:p>
@@ -6094,7 +6094,7 @@
               <a:spcAft>
                 <a:spcPts val="1200"/>
               </a:spcAft>
-              <a:defRPr sz="1700">
+              <a:defRPr sz="1900">
                 <a:solidFill>
                   <a:srgbClr val="333A4D"/>
                 </a:solidFill>
@@ -6109,7 +6109,7 @@
               <a:spcAft>
                 <a:spcPts val="1200"/>
               </a:spcAft>
-              <a:defRPr sz="1700">
+              <a:defRPr sz="1900">
                 <a:solidFill>
                   <a:srgbClr val="333A4D"/>
                 </a:solidFill>
@@ -6124,7 +6124,7 @@
               <a:spcAft>
                 <a:spcPts val="1200"/>
               </a:spcAft>
-              <a:defRPr sz="1700">
+              <a:defRPr sz="1900">
                 <a:solidFill>
                   <a:srgbClr val="333A4D"/>
                 </a:solidFill>

</xml_diff>